<commit_message>
Module 8 slides: say 'write a preview of your final project' on the Your week slide
Co-Authored-By: Claude Sonnet 5.5 <noreply@anthropic.com>
Claude-Session: https://claude.ai/code/session_01KXdMXMGRSgMavWy39gk8PG
</commit_message>
<xml_diff>
--- a/downloads/module-8-slides.pptx
+++ b/downloads/module-8-slides.pptx
@@ -2311,6 +2311,10 @@
             <a:prstDash val="solid"/>
           </a:ln>
         </p:spPr>
+        <p:txBody>
+          <a:bodyPr/>
+          <a:p/>
+        </p:txBody>
       </p:sp>
       <p:sp>
         <p:nvSpPr>
@@ -2453,6 +2457,10 @@
             <a:prstDash val="solid"/>
           </a:ln>
         </p:spPr>
+        <p:txBody>
+          <a:bodyPr/>
+          <a:p/>
+        </p:txBody>
       </p:sp>
       <p:sp>
         <p:nvSpPr>
@@ -2595,6 +2603,10 @@
             <a:prstDash val="solid"/>
           </a:ln>
         </p:spPr>
+        <p:txBody>
+          <a:bodyPr/>
+          <a:p/>
+        </p:txBody>
       </p:sp>
       <p:sp>
         <p:nvSpPr>
@@ -2739,6 +2751,10 @@
             <a:prstDash val="solid"/>
           </a:ln>
         </p:spPr>
+        <p:txBody>
+          <a:bodyPr/>
+          <a:p/>
+        </p:txBody>
       </p:sp>
       <p:sp>
         <p:nvSpPr>
@@ -2915,6 +2931,10 @@
             <a:prstDash val="solid"/>
           </a:ln>
         </p:spPr>
+        <p:txBody>
+          <a:bodyPr/>
+          <a:p/>
+        </p:txBody>
       </p:sp>
       <p:sp>
         <p:nvSpPr>
@@ -3134,6 +3154,10 @@
             <a:prstDash val="solid"/>
           </a:ln>
         </p:spPr>
+        <p:txBody>
+          <a:bodyPr/>
+          <a:p/>
+        </p:txBody>
       </p:sp>
       <p:sp>
         <p:nvSpPr>
@@ -3159,6 +3183,10 @@
             <a:prstDash val="solid"/>
           </a:ln>
         </p:spPr>
+        <p:txBody>
+          <a:bodyPr/>
+          <a:p/>
+        </p:txBody>
       </p:sp>
       <p:sp>
         <p:nvSpPr>
@@ -3374,6 +3402,10 @@
             <a:prstDash val="solid"/>
           </a:ln>
         </p:spPr>
+        <p:txBody>
+          <a:bodyPr/>
+          <a:p/>
+        </p:txBody>
       </p:sp>
       <p:sp>
         <p:nvSpPr>
@@ -3399,6 +3431,10 @@
             <a:prstDash val="solid"/>
           </a:ln>
         </p:spPr>
+        <p:txBody>
+          <a:bodyPr/>
+          <a:p/>
+        </p:txBody>
       </p:sp>
       <p:sp>
         <p:nvSpPr>
@@ -3504,6 +3540,10 @@
             <a:prstDash val="solid"/>
           </a:ln>
         </p:spPr>
+        <p:txBody>
+          <a:bodyPr/>
+          <a:p/>
+        </p:txBody>
       </p:sp>
       <p:sp>
         <p:nvSpPr>
@@ -3529,6 +3569,10 @@
             <a:prstDash val="solid"/>
           </a:ln>
         </p:spPr>
+        <p:txBody>
+          <a:bodyPr/>
+          <a:p/>
+        </p:txBody>
       </p:sp>
       <p:sp>
         <p:nvSpPr>
@@ -3878,7 +3922,7 @@
                 <a:ea typeface="Calibri" pitchFamily="34" charset="-122"/>
                 <a:cs typeface="Calibri" pitchFamily="34" charset="-120"/>
               </a:rPr>
-              <a:t>Check two findings yourself; write the machine card; pick a lens for your final-project idea</a:t>
+              <a:t>Check two findings yourself; write the machine card; write a preview of your final project</a:t>
             </a:r>
             <a:endParaRPr lang="en-US" sz="2300" dirty="0"/>
           </a:p>
@@ -4080,6 +4124,10 @@
             <a:prstDash val="solid"/>
           </a:ln>
         </p:spPr>
+        <p:txBody>
+          <a:bodyPr/>
+          <a:p/>
+        </p:txBody>
       </p:sp>
       <p:sp>
         <p:nvSpPr>
@@ -4224,6 +4272,10 @@
             <a:prstDash val="solid"/>
           </a:ln>
         </p:spPr>
+        <p:txBody>
+          <a:bodyPr/>
+          <a:p/>
+        </p:txBody>
       </p:sp>
       <p:sp>
         <p:nvSpPr>
@@ -4368,6 +4420,10 @@
             <a:prstDash val="solid"/>
           </a:ln>
         </p:spPr>
+        <p:txBody>
+          <a:bodyPr/>
+          <a:p/>
+        </p:txBody>
       </p:sp>
       <p:sp>
         <p:nvSpPr>
@@ -4661,6 +4717,10 @@
             <a:prstDash val="solid"/>
           </a:ln>
         </p:spPr>
+        <p:txBody>
+          <a:bodyPr/>
+          <a:p/>
+        </p:txBody>
       </p:sp>
       <p:sp>
         <p:nvSpPr>
@@ -4764,6 +4824,10 @@
             <a:prstDash val="solid"/>
           </a:ln>
         </p:spPr>
+        <p:txBody>
+          <a:bodyPr/>
+          <a:p/>
+        </p:txBody>
       </p:sp>
       <p:sp>
         <p:nvSpPr>
@@ -4791,6 +4855,10 @@
             <a:prstDash val="solid"/>
           </a:ln>
         </p:spPr>
+        <p:txBody>
+          <a:bodyPr/>
+          <a:p/>
+        </p:txBody>
       </p:sp>
       <p:sp>
         <p:nvSpPr>
@@ -4894,6 +4962,10 @@
             <a:prstDash val="solid"/>
           </a:ln>
         </p:spPr>
+        <p:txBody>
+          <a:bodyPr/>
+          <a:p/>
+        </p:txBody>
       </p:sp>
       <p:sp>
         <p:nvSpPr>
@@ -4921,6 +4993,10 @@
             <a:prstDash val="solid"/>
           </a:ln>
         </p:spPr>
+        <p:txBody>
+          <a:bodyPr/>
+          <a:p/>
+        </p:txBody>
       </p:sp>
       <p:sp>
         <p:nvSpPr>
@@ -5024,6 +5100,10 @@
             <a:prstDash val="solid"/>
           </a:ln>
         </p:spPr>
+        <p:txBody>
+          <a:bodyPr/>
+          <a:p/>
+        </p:txBody>
       </p:sp>
       <p:sp>
         <p:nvSpPr>
@@ -5051,6 +5131,10 @@
             <a:prstDash val="solid"/>
           </a:ln>
         </p:spPr>
+        <p:txBody>
+          <a:bodyPr/>
+          <a:p/>
+        </p:txBody>
       </p:sp>
       <p:sp>
         <p:nvSpPr>
@@ -5156,6 +5240,10 @@
             <a:prstDash val="solid"/>
           </a:ln>
         </p:spPr>
+        <p:txBody>
+          <a:bodyPr/>
+          <a:p/>
+        </p:txBody>
       </p:sp>
       <p:sp>
         <p:nvSpPr>
@@ -5236,6 +5324,10 @@
             <a:prstDash val="solid"/>
           </a:ln>
         </p:spPr>
+        <p:txBody>
+          <a:bodyPr/>
+          <a:p/>
+        </p:txBody>
       </p:sp>
       <p:sp>
         <p:nvSpPr>
@@ -5316,6 +5408,10 @@
             <a:prstDash val="solid"/>
           </a:ln>
         </p:spPr>
+        <p:txBody>
+          <a:bodyPr/>
+          <a:p/>
+        </p:txBody>
       </p:sp>
       <p:sp>
         <p:nvSpPr>
@@ -5341,6 +5437,10 @@
             <a:prstDash val="solid"/>
           </a:ln>
         </p:spPr>
+        <p:txBody>
+          <a:bodyPr/>
+          <a:p/>
+        </p:txBody>
       </p:sp>
       <p:sp>
         <p:nvSpPr>
@@ -5446,6 +5546,10 @@
             <a:prstDash val="solid"/>
           </a:ln>
         </p:spPr>
+        <p:txBody>
+          <a:bodyPr/>
+          <a:p/>
+        </p:txBody>
       </p:sp>
       <p:sp>
         <p:nvSpPr>
@@ -5471,6 +5575,10 @@
             <a:prstDash val="solid"/>
           </a:ln>
         </p:spPr>
+        <p:txBody>
+          <a:bodyPr/>
+          <a:p/>
+        </p:txBody>
       </p:sp>
       <p:sp>
         <p:nvSpPr>
@@ -5762,6 +5870,10 @@
             <a:prstDash val="solid"/>
           </a:ln>
         </p:spPr>
+        <p:txBody>
+          <a:bodyPr/>
+          <a:p/>
+        </p:txBody>
       </p:sp>
       <p:sp>
         <p:nvSpPr>
@@ -5865,6 +5977,10 @@
             <a:prstDash val="solid"/>
           </a:ln>
         </p:spPr>
+        <p:txBody>
+          <a:bodyPr/>
+          <a:p/>
+        </p:txBody>
       </p:sp>
       <p:sp>
         <p:nvSpPr>
@@ -5968,6 +6084,10 @@
             <a:prstDash val="solid"/>
           </a:ln>
         </p:spPr>
+        <p:txBody>
+          <a:bodyPr/>
+          <a:p/>
+        </p:txBody>
       </p:sp>
       <p:sp>
         <p:nvSpPr>
@@ -6071,6 +6191,10 @@
             <a:prstDash val="solid"/>
           </a:ln>
         </p:spPr>
+        <p:txBody>
+          <a:bodyPr/>
+          <a:p/>
+        </p:txBody>
       </p:sp>
       <p:sp>
         <p:nvSpPr>
@@ -6176,6 +6300,10 @@
             <a:prstDash val="solid"/>
           </a:ln>
         </p:spPr>
+        <p:txBody>
+          <a:bodyPr/>
+          <a:p/>
+        </p:txBody>
       </p:sp>
       <p:sp>
         <p:nvSpPr>
@@ -6397,6 +6525,10 @@
             <a:prstDash val="solid"/>
           </a:ln>
         </p:spPr>
+        <p:txBody>
+          <a:bodyPr/>
+          <a:p/>
+        </p:txBody>
       </p:sp>
       <p:sp>
         <p:nvSpPr>
@@ -6422,6 +6554,10 @@
             <a:prstDash val="solid"/>
           </a:ln>
         </p:spPr>
+        <p:txBody>
+          <a:bodyPr/>
+          <a:p/>
+        </p:txBody>
       </p:sp>
       <p:sp>
         <p:nvSpPr>
@@ -6527,6 +6663,10 @@
             <a:prstDash val="solid"/>
           </a:ln>
         </p:spPr>
+        <p:txBody>
+          <a:bodyPr/>
+          <a:p/>
+        </p:txBody>
       </p:sp>
       <p:sp>
         <p:nvSpPr>
@@ -6552,6 +6692,10 @@
             <a:prstDash val="solid"/>
           </a:ln>
         </p:spPr>
+        <p:txBody>
+          <a:bodyPr/>
+          <a:p/>
+        </p:txBody>
       </p:sp>
       <p:sp>
         <p:nvSpPr>
@@ -6657,6 +6801,10 @@
             <a:prstDash val="solid"/>
           </a:ln>
         </p:spPr>
+        <p:txBody>
+          <a:bodyPr/>
+          <a:p/>
+        </p:txBody>
       </p:sp>
       <p:sp>
         <p:nvSpPr>
@@ -6682,6 +6830,10 @@
             <a:prstDash val="solid"/>
           </a:ln>
         </p:spPr>
+        <p:txBody>
+          <a:bodyPr/>
+          <a:p/>
+        </p:txBody>
       </p:sp>
       <p:sp>
         <p:nvSpPr>
@@ -6787,6 +6939,10 @@
             <a:prstDash val="solid"/>
           </a:ln>
         </p:spPr>
+        <p:txBody>
+          <a:bodyPr/>
+          <a:p/>
+        </p:txBody>
       </p:sp>
       <p:sp>
         <p:nvSpPr>
@@ -6812,6 +6968,10 @@
             <a:prstDash val="solid"/>
           </a:ln>
         </p:spPr>
+        <p:txBody>
+          <a:bodyPr/>
+          <a:p/>
+        </p:txBody>
       </p:sp>
       <p:sp>
         <p:nvSpPr>
@@ -6917,6 +7077,10 @@
             <a:prstDash val="solid"/>
           </a:ln>
         </p:spPr>
+        <p:txBody>
+          <a:bodyPr/>
+          <a:p/>
+        </p:txBody>
       </p:sp>
       <p:sp>
         <p:nvSpPr>
@@ -7138,6 +7302,10 @@
             <a:prstDash val="solid"/>
           </a:ln>
         </p:spPr>
+        <p:txBody>
+          <a:bodyPr/>
+          <a:p/>
+        </p:txBody>
       </p:sp>
       <p:sp>
         <p:nvSpPr>
@@ -7163,6 +7331,10 @@
             <a:prstDash val="solid"/>
           </a:ln>
         </p:spPr>
+        <p:txBody>
+          <a:bodyPr/>
+          <a:p/>
+        </p:txBody>
       </p:sp>
       <p:sp>
         <p:nvSpPr>
@@ -7268,6 +7440,10 @@
             <a:prstDash val="solid"/>
           </a:ln>
         </p:spPr>
+        <p:txBody>
+          <a:bodyPr/>
+          <a:p/>
+        </p:txBody>
       </p:sp>
       <p:sp>
         <p:nvSpPr>
@@ -7293,6 +7469,10 @@
             <a:prstDash val="solid"/>
           </a:ln>
         </p:spPr>
+        <p:txBody>
+          <a:bodyPr/>
+          <a:p/>
+        </p:txBody>
       </p:sp>
       <p:sp>
         <p:nvSpPr>
@@ -7684,6 +7864,10 @@
             <a:prstDash val="solid"/>
           </a:ln>
         </p:spPr>
+        <p:txBody>
+          <a:bodyPr/>
+          <a:p/>
+        </p:txBody>
       </p:sp>
       <p:sp>
         <p:nvSpPr>
@@ -7711,6 +7895,10 @@
             <a:prstDash val="solid"/>
           </a:ln>
         </p:spPr>
+        <p:txBody>
+          <a:bodyPr/>
+          <a:p/>
+        </p:txBody>
       </p:sp>
       <p:sp>
         <p:nvSpPr>
@@ -7738,6 +7926,10 @@
             <a:prstDash val="solid"/>
           </a:ln>
         </p:spPr>
+        <p:txBody>
+          <a:bodyPr/>
+          <a:p/>
+        </p:txBody>
       </p:sp>
       <p:sp>
         <p:nvSpPr>
@@ -7765,6 +7957,10 @@
             <a:prstDash val="solid"/>
           </a:ln>
         </p:spPr>
+        <p:txBody>
+          <a:bodyPr/>
+          <a:p/>
+        </p:txBody>
       </p:sp>
       <p:sp>
         <p:nvSpPr>
@@ -7792,6 +7988,10 @@
             <a:prstDash val="solid"/>
           </a:ln>
         </p:spPr>
+        <p:txBody>
+          <a:bodyPr/>
+          <a:p/>
+        </p:txBody>
       </p:sp>
       <p:sp>
         <p:nvSpPr>
@@ -7819,6 +8019,10 @@
             <a:prstDash val="solid"/>
           </a:ln>
         </p:spPr>
+        <p:txBody>
+          <a:bodyPr/>
+          <a:p/>
+        </p:txBody>
       </p:sp>
       <p:sp>
         <p:nvSpPr>
@@ -7846,6 +8050,10 @@
             <a:prstDash val="solid"/>
           </a:ln>
         </p:spPr>
+        <p:txBody>
+          <a:bodyPr/>
+          <a:p/>
+        </p:txBody>
       </p:sp>
       <p:sp>
         <p:nvSpPr>
@@ -7873,6 +8081,10 @@
             <a:prstDash val="solid"/>
           </a:ln>
         </p:spPr>
+        <p:txBody>
+          <a:bodyPr/>
+          <a:p/>
+        </p:txBody>
       </p:sp>
       <p:sp>
         <p:nvSpPr>
@@ -7900,6 +8112,10 @@
             <a:prstDash val="solid"/>
           </a:ln>
         </p:spPr>
+        <p:txBody>
+          <a:bodyPr/>
+          <a:p/>
+        </p:txBody>
       </p:sp>
       <p:sp>
         <p:nvSpPr>
@@ -7927,6 +8143,10 @@
             <a:prstDash val="solid"/>
           </a:ln>
         </p:spPr>
+        <p:txBody>
+          <a:bodyPr/>
+          <a:p/>
+        </p:txBody>
       </p:sp>
       <p:sp>
         <p:nvSpPr>
@@ -7954,6 +8174,10 @@
             <a:prstDash val="solid"/>
           </a:ln>
         </p:spPr>
+        <p:txBody>
+          <a:bodyPr/>
+          <a:p/>
+        </p:txBody>
       </p:sp>
       <p:sp>
         <p:nvSpPr>
@@ -7981,6 +8205,10 @@
             <a:prstDash val="solid"/>
           </a:ln>
         </p:spPr>
+        <p:txBody>
+          <a:bodyPr/>
+          <a:p/>
+        </p:txBody>
       </p:sp>
       <p:sp>
         <p:nvSpPr>
@@ -8008,6 +8236,10 @@
             <a:prstDash val="solid"/>
           </a:ln>
         </p:spPr>
+        <p:txBody>
+          <a:bodyPr/>
+          <a:p/>
+        </p:txBody>
       </p:sp>
       <p:sp>
         <p:nvSpPr>
@@ -8035,6 +8267,10 @@
             <a:prstDash val="solid"/>
           </a:ln>
         </p:spPr>
+        <p:txBody>
+          <a:bodyPr/>
+          <a:p/>
+        </p:txBody>
       </p:sp>
       <p:sp>
         <p:nvSpPr>
@@ -8140,6 +8376,10 @@
             <a:prstDash val="solid"/>
           </a:ln>
         </p:spPr>
+        <p:txBody>
+          <a:bodyPr/>
+          <a:p/>
+        </p:txBody>
       </p:sp>
       <p:sp>
         <p:nvSpPr>
@@ -8165,6 +8405,10 @@
             <a:prstDash val="solid"/>
           </a:ln>
         </p:spPr>
+        <p:txBody>
+          <a:bodyPr/>
+          <a:p/>
+        </p:txBody>
       </p:sp>
       <p:sp>
         <p:nvSpPr>
@@ -8270,6 +8514,10 @@
             <a:prstDash val="solid"/>
           </a:ln>
         </p:spPr>
+        <p:txBody>
+          <a:bodyPr/>
+          <a:p/>
+        </p:txBody>
       </p:sp>
       <p:sp>
         <p:nvSpPr>
@@ -8295,6 +8543,10 @@
             <a:prstDash val="solid"/>
           </a:ln>
         </p:spPr>
+        <p:txBody>
+          <a:bodyPr/>
+          <a:p/>
+        </p:txBody>
       </p:sp>
       <p:sp>
         <p:nvSpPr>
@@ -8400,6 +8652,10 @@
             <a:prstDash val="solid"/>
           </a:ln>
         </p:spPr>
+        <p:txBody>
+          <a:bodyPr/>
+          <a:p/>
+        </p:txBody>
       </p:sp>
       <p:sp>
         <p:nvSpPr>
@@ -8425,6 +8681,10 @@
             <a:prstDash val="solid"/>
           </a:ln>
         </p:spPr>
+        <p:txBody>
+          <a:bodyPr/>
+          <a:p/>
+        </p:txBody>
       </p:sp>
       <p:sp>
         <p:nvSpPr>
@@ -8530,6 +8790,10 @@
             <a:prstDash val="solid"/>
           </a:ln>
         </p:spPr>
+        <p:txBody>
+          <a:bodyPr/>
+          <a:p/>
+        </p:txBody>
       </p:sp>
       <p:sp>
         <p:nvSpPr>
@@ -8720,6 +8984,10 @@
             <a:prstDash val="solid"/>
           </a:ln>
         </p:spPr>
+        <p:txBody>
+          <a:bodyPr/>
+          <a:p/>
+        </p:txBody>
       </p:sp>
       <p:sp>
         <p:nvSpPr>
@@ -8745,6 +9013,10 @@
             <a:prstDash val="solid"/>
           </a:ln>
         </p:spPr>
+        <p:txBody>
+          <a:bodyPr/>
+          <a:p/>
+        </p:txBody>
       </p:sp>
       <p:sp>
         <p:nvSpPr>
@@ -8850,6 +9122,10 @@
             <a:prstDash val="solid"/>
           </a:ln>
         </p:spPr>
+        <p:txBody>
+          <a:bodyPr/>
+          <a:p/>
+        </p:txBody>
       </p:sp>
       <p:sp>
         <p:nvSpPr>
@@ -9180,6 +9456,10 @@
             <a:prstDash val="solid"/>
           </a:ln>
         </p:spPr>
+        <p:txBody>
+          <a:bodyPr/>
+          <a:p/>
+        </p:txBody>
       </p:sp>
       <p:sp>
         <p:nvSpPr>
@@ -9322,6 +9602,10 @@
             <a:prstDash val="solid"/>
           </a:ln>
         </p:spPr>
+        <p:txBody>
+          <a:bodyPr/>
+          <a:p/>
+        </p:txBody>
       </p:sp>
       <p:sp>
         <p:nvSpPr>
@@ -9464,6 +9748,10 @@
             <a:prstDash val="solid"/>
           </a:ln>
         </p:spPr>
+        <p:txBody>
+          <a:bodyPr/>
+          <a:p/>
+        </p:txBody>
       </p:sp>
       <p:sp>
         <p:nvSpPr>
@@ -9684,6 +9972,10 @@
             <a:prstDash val="solid"/>
           </a:ln>
         </p:spPr>
+        <p:txBody>
+          <a:bodyPr/>
+          <a:p/>
+        </p:txBody>
       </p:sp>
       <p:sp>
         <p:nvSpPr>
@@ -9787,6 +10079,10 @@
             <a:prstDash val="solid"/>
           </a:ln>
         </p:spPr>
+        <p:txBody>
+          <a:bodyPr/>
+          <a:p/>
+        </p:txBody>
       </p:sp>
       <p:sp>
         <p:nvSpPr>

</xml_diff>